<commit_message>
Add 2-page judge brief; fix category count (18) and proxy overhead range in deck and team docs
Co-Authored-By: Claude Opus 5.5 <noreply@anthropic.com>
Claude-Session: https://claude.ai/code/session_0137YjjALDCZ2ScREk2SyYd1
</commit_message>
<xml_diff>
--- a/presentation/Provenant_Hackathon_Final.pptx
+++ b/presentation/Provenant_Hackathon_Final.pptx
@@ -117,14 +117,14 @@
   <p:extLst>
     <p:ext uri="{521415D9-36F7-43E2-AB2F-B90AF26B5E84}">
       <p14:sectionLst xmlns:p14="http://schemas.microsoft.com/office/powerpoint/2010/main">
-        <p14:section name="Problem and vision" id="{967e2f44-5f36-056c-0adf-e3f6a3134416}">
+        <p14:section name="Problem and vision" id="{82589f59-57ca-2edd-5154-a89d4e548e18}">
           <p14:sldIdLst>
             <p14:sldId id="256"/>
             <p14:sldId id="257"/>
             <p14:sldId id="258"/>
           </p14:sldIdLst>
         </p14:section>
-        <p14:section name="Architecture and enforcement" id="{3908eb00-067b-e1aa-80bb-429708a97ded}">
+        <p14:section name="Architecture and enforcement" id="{7bbe3340-7365-7775-4fdb-db05677a553c}">
           <p14:sldIdLst>
             <p14:sldId id="259"/>
             <p14:sldId id="260"/>
@@ -132,7 +132,7 @@
             <p14:sldId id="262"/>
           </p14:sldIdLst>
         </p14:section>
-        <p14:section name="Demo, evaluation and close" id="{e73c8bdc-c69c-aaf6-2ff1-12fafdf1267c}">
+        <p14:section name="Demo, evaluation and close" id="{1db6c69d-44dc-602e-11c9-23b5d84b5adf}">
           <p14:sldIdLst>
             <p14:sldId id="263"/>
             <p14:sldId id="264"/>
@@ -175,7 +175,7 @@
                 </a:solidFill>
                 <a:latin typeface="+mn-lt"/>
               </a:rPr>
-              <a:t>Attacks contained by category (all 100%)</a:t>
+              <a:t>Largest 12 of 18 attack categories (all 100% contained)</a:t>
             </a:r>
           </a:p>
         </c:rich>
@@ -1736,7 +1736,7 @@
           <a:p>
             <a:r>
               <a:rPr lang="en-US" dirty="0"/>
-              <a:t>P3. 40 seconds. Numbers come from python evals/run_eval.py, rerun today. 225 attacks across 15 categories: every one is DENY or REQUIRE_APPROVAL, never ALLOW. 53 legitimate actions all allowed: no false positives. Mention round 2: we red-teamed ourselves and found 41 gaps, fixed them. The categories not shown (taint, classify, failclosed) are also 100%.</a:t>
+              <a:t>P3. 40 seconds. Numbers come from python evals/run_eval.py, rerun today. 225 attacks across 18 categories: every one is DENY or REQUIRE_APPROVAL, never ALLOW. 53 legitimate actions all allowed: no false positives. Mention round 2: we red-teamed ourselves and found 41 gaps, fixed them. The six smaller categories not on the chart (injection, persist, evasion, taint, classify, failclosed) are also 100%.</a:t>
             </a:r>
             <a:endParaRPr lang="en-US" dirty="0"/>
           </a:p>

</xml_diff>

<commit_message>
Docs, deck, handouts and briefings match 0.10.3; handoff log updated
- deck: 231/231, 11/11, 257 tests, 0.2 ms; slide 4 says unknown tools are held and
  only calls through the three doors are protected; speaker notes match the 8-slide deck
- judge brief and tech stack PDFs regenerated with the new numbers and fail-closed wording
- teammate briefing PDFs regenerated from the scripts (they still described the old
  11-slide deck); P2 script covers observe-vs-prevent and self-protection
- FINAL_TEST_REPORT for 0.10.3 (bug table, what ran, what did not), UPDATE.md, CLAUDE.md

Co-Authored-By: Claude Opus 5.5 <noreply@anthropic.com>
Claude-Session: https://claude.ai/code/session_0137Yjj9f7xxe77Ag3Tog2Nq
</commit_message>
<xml_diff>
--- a/presentation/Provenant_Hackathon_Final.pptx
+++ b/presentation/Provenant_Hackathon_Final.pptx
@@ -773,7 +773,7 @@
           <a:p>
             <a:r>
               <a:rPr lang="en-US" dirty="0"/>
-              <a:t>P2. 60 seconds. The decision isn't made by a model. Three ways in: MCP clients through our proxy, Claude Code through its hooks, and our own gated tool server. All call the same Guard.check, written in plain Python. Three answers: ALLOW runs once under a single-use grant tied to that exact call; DENY never reaches the tool; REQUIRE APPROVAL waits for a person. It fails closed. The loop at the bottom matters most: reading a malicious email changes what the agent is allowed to do next. An optional advisory model exists but can only escalate, never allow.</a:t>
+              <a:t>P2. 60 seconds. The decision isn't made by a model. Three ways in: MCP clients through our proxy, Claude Code through its hooks, and our own gated tool server. All call the same Guard.check, written in plain Python. Three answers: ALLOW runs once under a single-use grant tied to that exact call; DENY never reaches the tool; REQUIRE APPROVAL waits for a person. It fails closed. The loop at the bottom matters most: reading a malicious email changes what the agent is allowed to do next. An optional advisory model exists but can only escalate, never allow. Say the boundary plainly: only calls that go through these three doors are protected. A remote HTTP MCP server, or an agent calling an API from its own code, is invisible to us, and provenant status never says 'connected' until real tool traffic has gone through. docs/COVERAGE.md has the table.</a:t>
             </a:r>
             <a:endParaRPr lang="en-US" dirty="0"/>
           </a:p>
@@ -1037,7 +1037,7 @@
           <a:p>
             <a:r>
               <a:rPr lang="en-US" dirty="0"/>
-              <a:t>P3. 40 seconds. Numbers come from python evals/run_eval.py, rerun today. Each square is one attack: 225 across 18 categories, every one DENY (green) or REQUIRE_APPROVAL (amber), never ALLOW. 53 legitimate actions all allowed: no false positives. Round 2: we red-teamed ourselves and found 41 gaps, all fixed. Proxy overhead per call is roughly 15 to 25 ms depending on the machine. Bonus: the gated tool server shapes output, so on our 15-step benchmark tool-result tokens fell 72% (52,432 to 14,541), task still completed; one scripted workload, tokens estimated. Then read the limits strip out loud before the judges ask.</a:t>
+              <a:t>P3. 40 seconds. Numbers come from python evals/run_eval.py, rerun today. Each square is one attack: 231 across 18 categories, every one DENY (green) or REQUIRE_APPROVAL (amber), never ALLOW. 53 legitimate actions all allowed: no false positives. Round 2: we red-teamed ourselves and found 41 gaps, all fixed. Proxy overhead per call is roughly 15 to 25 ms depending on the machine. Bonus: the gated tool server shapes output, so on our 15-step benchmark tool-result tokens fell 72% (52,432 to 14,541), task still completed; one scripted workload, tokens estimated. Then read the limits strip out loud before the judges ask.</a:t>
             </a:r>
             <a:endParaRPr lang="en-US" dirty="0"/>
           </a:p>
@@ -1668,7 +1668,7 @@
       </p:grpSpPr>
       <p:pic>
         <p:nvPicPr>
-          <p:cNvPr id="2" name="slide 4" descr="Architecture: MCP clients, Claude Code and the gated tool server all pass one deterministic gate that returns ALLOW, REQUIRE APPROVAL or DENY.">    </p:cNvPr>
+          <p:cNvPr id="2" name="slide 4" descr="Architecture: MCP clients, Claude Code and the gated tool server all pass one deterministic gate that returns ALLOW, REQUIRE APPROVAL or DENY. Only calls through these doors are protected.">    </p:cNvPr>
           <p:cNvPicPr>
             <a:picLocks noChangeAspect="1"/>
           </p:cNvPicPr>
@@ -1836,7 +1836,7 @@
       </p:grpSpPr>
       <p:pic>
         <p:nvPicPr>
-          <p:cNvPr id="2" name="slide 7" descr="Evaluation: 225 of 225 attacks contained, 53 of 53 legitimate actions allowed, 9 of 9 live checks, 235 tests, 72 percent fewer tool-result tokens, 0.15 ms decisions, 41 self-found gaps fixed.">    </p:cNvPr>
+          <p:cNvPr id="2" name="slide 7" descr="Evaluation: 231 of 231 attacks contained, 53 of 53 legitimate actions allowed, 11 of 11 live checks, 257 tests, 72 percent fewer tool-result tokens, 0.2 ms decisions, 41 self-found gaps fixed.">    </p:cNvPr>
           <p:cNvPicPr>
             <a:picLocks noChangeAspect="1"/>
           </p:cNvPicPr>

</xml_diff>